<commit_message>
Updated Grid4CHIL model with scaled output on "v" output signal
</commit_message>
<xml_diff>
--- a/docs/20251222-nucleo-pin-configurations.pptx
+++ b/docs/20251222-nucleo-pin-configurations.pptx
@@ -105,6 +105,11 @@
       </a:defRPr>
     </a:lvl9pPr>
   </p:defaultTextStyle>
+  <p:extLst>
+    <p:ext uri="{EFAFB233-063F-42B5-8137-9DF3F51BA10A}">
+      <p15:sldGuideLst xmlns:p15="http://schemas.microsoft.com/office/powerpoint/2012/main"/>
+    </p:ext>
+  </p:extLst>
 </p:presentation>
 </file>
 
@@ -255,7 +260,7 @@
           <a:p>
             <a:fld id="{B8B67C60-164F-4645-BD88-C03E7D28266F}" type="datetimeFigureOut">
               <a:rPr lang="en-US" smtClean="0"/>
-              <a:t>12/22/2025</a:t>
+              <a:t>3/20/2026</a:t>
             </a:fld>
             <a:endParaRPr lang="en-US"/>
           </a:p>
@@ -453,7 +458,7 @@
           <a:p>
             <a:fld id="{B8B67C60-164F-4645-BD88-C03E7D28266F}" type="datetimeFigureOut">
               <a:rPr lang="en-US" smtClean="0"/>
-              <a:t>12/22/2025</a:t>
+              <a:t>3/20/2026</a:t>
             </a:fld>
             <a:endParaRPr lang="en-US"/>
           </a:p>
@@ -661,7 +666,7 @@
           <a:p>
             <a:fld id="{B8B67C60-164F-4645-BD88-C03E7D28266F}" type="datetimeFigureOut">
               <a:rPr lang="en-US" smtClean="0"/>
-              <a:t>12/22/2025</a:t>
+              <a:t>3/20/2026</a:t>
             </a:fld>
             <a:endParaRPr lang="en-US"/>
           </a:p>
@@ -859,7 +864,7 @@
           <a:p>
             <a:fld id="{B8B67C60-164F-4645-BD88-C03E7D28266F}" type="datetimeFigureOut">
               <a:rPr lang="en-US" smtClean="0"/>
-              <a:t>12/22/2025</a:t>
+              <a:t>3/20/2026</a:t>
             </a:fld>
             <a:endParaRPr lang="en-US"/>
           </a:p>
@@ -1134,7 +1139,7 @@
           <a:p>
             <a:fld id="{B8B67C60-164F-4645-BD88-C03E7D28266F}" type="datetimeFigureOut">
               <a:rPr lang="en-US" smtClean="0"/>
-              <a:t>12/22/2025</a:t>
+              <a:t>3/20/2026</a:t>
             </a:fld>
             <a:endParaRPr lang="en-US"/>
           </a:p>
@@ -1399,7 +1404,7 @@
           <a:p>
             <a:fld id="{B8B67C60-164F-4645-BD88-C03E7D28266F}" type="datetimeFigureOut">
               <a:rPr lang="en-US" smtClean="0"/>
-              <a:t>12/22/2025</a:t>
+              <a:t>3/20/2026</a:t>
             </a:fld>
             <a:endParaRPr lang="en-US"/>
           </a:p>
@@ -1811,7 +1816,7 @@
           <a:p>
             <a:fld id="{B8B67C60-164F-4645-BD88-C03E7D28266F}" type="datetimeFigureOut">
               <a:rPr lang="en-US" smtClean="0"/>
-              <a:t>12/22/2025</a:t>
+              <a:t>3/20/2026</a:t>
             </a:fld>
             <a:endParaRPr lang="en-US"/>
           </a:p>
@@ -1952,7 +1957,7 @@
           <a:p>
             <a:fld id="{B8B67C60-164F-4645-BD88-C03E7D28266F}" type="datetimeFigureOut">
               <a:rPr lang="en-US" smtClean="0"/>
-              <a:t>12/22/2025</a:t>
+              <a:t>3/20/2026</a:t>
             </a:fld>
             <a:endParaRPr lang="en-US"/>
           </a:p>
@@ -2065,7 +2070,7 @@
           <a:p>
             <a:fld id="{B8B67C60-164F-4645-BD88-C03E7D28266F}" type="datetimeFigureOut">
               <a:rPr lang="en-US" smtClean="0"/>
-              <a:t>12/22/2025</a:t>
+              <a:t>3/20/2026</a:t>
             </a:fld>
             <a:endParaRPr lang="en-US"/>
           </a:p>
@@ -2376,7 +2381,7 @@
           <a:p>
             <a:fld id="{B8B67C60-164F-4645-BD88-C03E7D28266F}" type="datetimeFigureOut">
               <a:rPr lang="en-US" smtClean="0"/>
-              <a:t>12/22/2025</a:t>
+              <a:t>3/20/2026</a:t>
             </a:fld>
             <a:endParaRPr lang="en-US"/>
           </a:p>
@@ -2664,7 +2669,7 @@
           <a:p>
             <a:fld id="{B8B67C60-164F-4645-BD88-C03E7D28266F}" type="datetimeFigureOut">
               <a:rPr lang="en-US" smtClean="0"/>
-              <a:t>12/22/2025</a:t>
+              <a:t>3/20/2026</a:t>
             </a:fld>
             <a:endParaRPr lang="en-US"/>
           </a:p>
@@ -2905,7 +2910,7 @@
           <a:p>
             <a:fld id="{B8B67C60-164F-4645-BD88-C03E7D28266F}" type="datetimeFigureOut">
               <a:rPr lang="en-US" smtClean="0"/>
-              <a:t>12/22/2025</a:t>
+              <a:t>3/20/2026</a:t>
             </a:fld>
             <a:endParaRPr lang="en-US"/>
           </a:p>
@@ -3540,6 +3545,22 @@
             <a:avLst/>
           </a:prstGeom>
         </p:spPr>
+        <p:style>
+          <a:lnRef idx="2">
+            <a:schemeClr val="accent2">
+              <a:shade val="15000"/>
+            </a:schemeClr>
+          </a:lnRef>
+          <a:fillRef idx="1">
+            <a:schemeClr val="accent2"/>
+          </a:fillRef>
+          <a:effectRef idx="0">
+            <a:schemeClr val="accent2"/>
+          </a:effectRef>
+          <a:fontRef idx="minor">
+            <a:schemeClr val="lt1"/>
+          </a:fontRef>
+        </p:style>
       </p:pic>
       <p:pic>
         <p:nvPicPr>
@@ -4264,6 +4285,202 @@
           </a:fillRef>
           <a:effectRef idx="0">
             <a:schemeClr val="accent1"/>
+          </a:effectRef>
+          <a:fontRef idx="minor">
+            <a:schemeClr val="lt1"/>
+          </a:fontRef>
+        </p:style>
+        <p:txBody>
+          <a:bodyPr rtlCol="0" anchor="ctr"/>
+          <a:lstStyle/>
+          <a:p>
+            <a:pPr algn="ctr"/>
+            <a:endParaRPr lang="en-US"/>
+          </a:p>
+        </p:txBody>
+      </p:sp>
+      <p:sp>
+        <p:nvSpPr>
+          <p:cNvPr id="5" name="Rectangle 4">
+            <a:extLst>
+              <a:ext uri="{FF2B5EF4-FFF2-40B4-BE49-F238E27FC236}">
+                <a16:creationId xmlns:a16="http://schemas.microsoft.com/office/drawing/2014/main" id="{B827C3C6-BF5B-68C3-FF99-ED40E6A7A8B4}"/>
+              </a:ext>
+            </a:extLst>
+          </p:cNvPr>
+          <p:cNvSpPr/>
+          <p:nvPr/>
+        </p:nvSpPr>
+        <p:spPr>
+          <a:xfrm>
+            <a:off x="9234488" y="3028950"/>
+            <a:ext cx="146905" cy="246597"/>
+          </a:xfrm>
+          <a:prstGeom prst="rect">
+            <a:avLst/>
+          </a:prstGeom>
+          <a:noFill/>
+          <a:ln>
+            <a:solidFill>
+              <a:srgbClr val="FFC000"/>
+            </a:solidFill>
+          </a:ln>
+        </p:spPr>
+        <p:style>
+          <a:lnRef idx="2">
+            <a:schemeClr val="accent1">
+              <a:shade val="15000"/>
+            </a:schemeClr>
+          </a:lnRef>
+          <a:fillRef idx="1">
+            <a:schemeClr val="accent1"/>
+          </a:fillRef>
+          <a:effectRef idx="0">
+            <a:schemeClr val="accent1"/>
+          </a:effectRef>
+          <a:fontRef idx="minor">
+            <a:schemeClr val="lt1"/>
+          </a:fontRef>
+        </p:style>
+        <p:txBody>
+          <a:bodyPr rtlCol="0" anchor="ctr"/>
+          <a:lstStyle/>
+          <a:p>
+            <a:pPr algn="ctr"/>
+            <a:endParaRPr lang="en-US"/>
+          </a:p>
+        </p:txBody>
+      </p:sp>
+      <p:sp>
+        <p:nvSpPr>
+          <p:cNvPr id="14" name="Rectangle 13">
+            <a:extLst>
+              <a:ext uri="{FF2B5EF4-FFF2-40B4-BE49-F238E27FC236}">
+                <a16:creationId xmlns:a16="http://schemas.microsoft.com/office/drawing/2014/main" id="{EE2AE39B-04B1-C054-948D-F5EE67FD233A}"/>
+              </a:ext>
+            </a:extLst>
+          </p:cNvPr>
+          <p:cNvSpPr/>
+          <p:nvPr/>
+        </p:nvSpPr>
+        <p:spPr>
+          <a:xfrm>
+            <a:off x="8510294" y="5729288"/>
+            <a:ext cx="1303400" cy="95668"/>
+          </a:xfrm>
+          <a:prstGeom prst="rect">
+            <a:avLst/>
+          </a:prstGeom>
+          <a:noFill/>
+          <a:ln>
+            <a:solidFill>
+              <a:srgbClr val="FFC000"/>
+            </a:solidFill>
+          </a:ln>
+        </p:spPr>
+        <p:style>
+          <a:lnRef idx="2">
+            <a:schemeClr val="accent1">
+              <a:shade val="15000"/>
+            </a:schemeClr>
+          </a:lnRef>
+          <a:fillRef idx="1">
+            <a:schemeClr val="accent1"/>
+          </a:fillRef>
+          <a:effectRef idx="0">
+            <a:schemeClr val="accent1"/>
+          </a:effectRef>
+          <a:fontRef idx="minor">
+            <a:schemeClr val="lt1"/>
+          </a:fontRef>
+        </p:style>
+        <p:txBody>
+          <a:bodyPr rtlCol="0" anchor="ctr"/>
+          <a:lstStyle/>
+          <a:p>
+            <a:pPr algn="ctr"/>
+            <a:endParaRPr lang="en-US"/>
+          </a:p>
+        </p:txBody>
+      </p:sp>
+      <p:sp>
+        <p:nvSpPr>
+          <p:cNvPr id="17" name="Arrow: Right 16">
+            <a:extLst>
+              <a:ext uri="{FF2B5EF4-FFF2-40B4-BE49-F238E27FC236}">
+                <a16:creationId xmlns:a16="http://schemas.microsoft.com/office/drawing/2014/main" id="{9F59E3BC-F648-41C9-6170-DE468797AEC5}"/>
+              </a:ext>
+            </a:extLst>
+          </p:cNvPr>
+          <p:cNvSpPr/>
+          <p:nvPr/>
+        </p:nvSpPr>
+        <p:spPr>
+          <a:xfrm>
+            <a:off x="8949565" y="3015938"/>
+            <a:ext cx="276225" cy="323850"/>
+          </a:xfrm>
+          <a:prstGeom prst="rightArrow">
+            <a:avLst/>
+          </a:prstGeom>
+        </p:spPr>
+        <p:style>
+          <a:lnRef idx="2">
+            <a:schemeClr val="accent2">
+              <a:shade val="15000"/>
+            </a:schemeClr>
+          </a:lnRef>
+          <a:fillRef idx="1">
+            <a:schemeClr val="accent2"/>
+          </a:fillRef>
+          <a:effectRef idx="0">
+            <a:schemeClr val="accent2"/>
+          </a:effectRef>
+          <a:fontRef idx="minor">
+            <a:schemeClr val="lt1"/>
+          </a:fontRef>
+        </p:style>
+        <p:txBody>
+          <a:bodyPr rtlCol="0" anchor="ctr"/>
+          <a:lstStyle/>
+          <a:p>
+            <a:pPr algn="ctr"/>
+            <a:endParaRPr lang="en-US"/>
+          </a:p>
+        </p:txBody>
+      </p:sp>
+      <p:sp>
+        <p:nvSpPr>
+          <p:cNvPr id="18" name="Arrow: Right 17">
+            <a:extLst>
+              <a:ext uri="{FF2B5EF4-FFF2-40B4-BE49-F238E27FC236}">
+                <a16:creationId xmlns:a16="http://schemas.microsoft.com/office/drawing/2014/main" id="{FFAE3192-402D-82C9-7702-77B1C671B375}"/>
+              </a:ext>
+            </a:extLst>
+          </p:cNvPr>
+          <p:cNvSpPr/>
+          <p:nvPr/>
+        </p:nvSpPr>
+        <p:spPr>
+          <a:xfrm>
+            <a:off x="8234068" y="5569743"/>
+            <a:ext cx="276225" cy="323850"/>
+          </a:xfrm>
+          <a:prstGeom prst="rightArrow">
+            <a:avLst/>
+          </a:prstGeom>
+        </p:spPr>
+        <p:style>
+          <a:lnRef idx="2">
+            <a:schemeClr val="accent2">
+              <a:shade val="15000"/>
+            </a:schemeClr>
+          </a:lnRef>
+          <a:fillRef idx="1">
+            <a:schemeClr val="accent2"/>
+          </a:fillRef>
+          <a:effectRef idx="0">
+            <a:schemeClr val="accent2"/>
           </a:effectRef>
           <a:fontRef idx="minor">
             <a:schemeClr val="lt1"/>

</xml_diff>